<commit_message>
Remove repeated footer text and use full author name on cover
Co-Authored-By: Claude Opus 5.5 <noreply@anthropic.com>
Claude-Session: https://claude.ai/code/session_01ByhZihsxs47ZzCBh4j1m8z
</commit_message>
<xml_diff>
--- a/أساسيات كتابة البحث في التصميم - PNU.pptx
+++ b/أساسيات كتابة البحث في التصميم - PNU.pptx
@@ -2636,44 +2636,8 @@
         <p:nvSpPr>
           <p:cNvPr id="4" name="Text 2"/>
           <p:cNvSpPr/>
-          <p:nvPr/>
-        </p:nvSpPr>
-        <p:spPr>
-          <a:xfrm>
-            <a:off x="5760720" y="6355080"/>
-            <a:ext cx="5971032" cy="274320"/>
-          </a:xfrm>
-          <a:prstGeom prst="rect">
-            <a:avLst/>
-          </a:prstGeom>
-          <a:noFill/>
-          <a:ln/>
-        </p:spPr>
-        <p:txBody>
-          <a:bodyPr wrap="square" lIns="0" tIns="0" rIns="0" bIns="0" rtlCol="0" anchor="ctr"/>
-          <a:lstStyle/>
-          <a:p>
-            <a:pPr algn="r" indent="0" marL="0" rtl="1">
-              <a:buNone/>
-            </a:pPr>
-            <a:r>
-              <a:rPr lang="en-US" sz="1000" dirty="0">
-                <a:solidFill>
-                  <a:schemeClr val="accent4"/>
-                </a:solidFill>
-              </a:rPr>
-              <a:t>أساسيات كتابة البحث في التصميم</a:t>
-            </a:r>
-            <a:endParaRPr lang="en-US" sz="1000" dirty="0"/>
-          </a:p>
-        </p:txBody>
-      </p:sp>
-      <p:sp>
-        <p:nvSpPr>
-          <p:cNvPr id="5" name="Text 3"/>
-          <p:cNvSpPr/>
           <p:nvPr>
-            <p:ph idx="105" type="title" hasCustomPrompt="1"/>
+            <p:ph idx="104" type="title" hasCustomPrompt="1"/>
           </p:nvPr>
         </p:nvSpPr>
         <p:spPr>
@@ -3315,7 +3279,7 @@
                   <a:schemeClr val="accent2"/>
                 </a:solidFill>
               </a:rPr>
-              <a:t>إعداد: د. حنان الرشيد</a:t>
+              <a:t>إعداد: د. حنان بنت عبدالله الرشيد</a:t>
             </a:r>
             <a:endParaRPr lang="en-US" sz="2200" dirty="0"/>
           </a:p>
@@ -3348,10 +3312,10 @@
       </p:grpSpPr>
       <p:sp>
         <p:nvSpPr>
-          <p:cNvPr id="2" name="Text 3"/>
+          <p:cNvPr id="2" name="Text 2"/>
           <p:cNvSpPr/>
           <p:nvPr>
-            <p:ph idx="105" type="title" hasCustomPrompt="1"/>
+            <p:ph idx="104" type="title" hasCustomPrompt="1"/>
           </p:nvPr>
         </p:nvSpPr>
         <p:spPr>
@@ -4291,10 +4255,10 @@
       </p:grpSpPr>
       <p:sp>
         <p:nvSpPr>
-          <p:cNvPr id="2" name="Text 3"/>
+          <p:cNvPr id="2" name="Text 2"/>
           <p:cNvSpPr/>
           <p:nvPr>
-            <p:ph idx="105" type="title" hasCustomPrompt="1"/>
+            <p:ph idx="104" type="title" hasCustomPrompt="1"/>
           </p:nvPr>
         </p:nvSpPr>
         <p:spPr>
@@ -4915,10 +4879,10 @@
       </p:grpSpPr>
       <p:sp>
         <p:nvSpPr>
-          <p:cNvPr id="2" name="Text 3"/>
+          <p:cNvPr id="2" name="Text 2"/>
           <p:cNvSpPr/>
           <p:nvPr>
-            <p:ph idx="105" type="title" hasCustomPrompt="1"/>
+            <p:ph idx="104" type="title" hasCustomPrompt="1"/>
           </p:nvPr>
         </p:nvSpPr>
         <p:spPr>
@@ -5811,10 +5775,10 @@
       </p:grpSpPr>
       <p:sp>
         <p:nvSpPr>
-          <p:cNvPr id="2" name="Text 3"/>
+          <p:cNvPr id="2" name="Text 2"/>
           <p:cNvSpPr/>
           <p:nvPr>
-            <p:ph idx="105" type="title" hasCustomPrompt="1"/>
+            <p:ph idx="104" type="title" hasCustomPrompt="1"/>
           </p:nvPr>
         </p:nvSpPr>
         <p:spPr>
@@ -6729,10 +6693,10 @@
       </p:grpSpPr>
       <p:sp>
         <p:nvSpPr>
-          <p:cNvPr id="2" name="Text 3"/>
+          <p:cNvPr id="2" name="Text 2"/>
           <p:cNvSpPr/>
           <p:nvPr>
-            <p:ph idx="105" type="title" hasCustomPrompt="1"/>
+            <p:ph idx="104" type="title" hasCustomPrompt="1"/>
           </p:nvPr>
         </p:nvSpPr>
         <p:spPr>
@@ -7590,10 +7554,10 @@
       </p:grpSpPr>
       <p:sp>
         <p:nvSpPr>
-          <p:cNvPr id="2" name="Text 3"/>
+          <p:cNvPr id="2" name="Text 2"/>
           <p:cNvSpPr/>
           <p:nvPr>
-            <p:ph idx="105" type="title" hasCustomPrompt="1"/>
+            <p:ph idx="104" type="title" hasCustomPrompt="1"/>
           </p:nvPr>
         </p:nvSpPr>
         <p:spPr>
@@ -8428,10 +8392,10 @@
       </p:grpSpPr>
       <p:sp>
         <p:nvSpPr>
-          <p:cNvPr id="2" name="Text 3"/>
+          <p:cNvPr id="2" name="Text 2"/>
           <p:cNvSpPr/>
           <p:nvPr>
-            <p:ph idx="105" type="title" hasCustomPrompt="1"/>
+            <p:ph idx="104" type="title" hasCustomPrompt="1"/>
           </p:nvPr>
         </p:nvSpPr>
         <p:spPr>
@@ -9178,10 +9142,10 @@
       </p:grpSpPr>
       <p:sp>
         <p:nvSpPr>
-          <p:cNvPr id="2" name="Text 3"/>
+          <p:cNvPr id="2" name="Text 2"/>
           <p:cNvSpPr/>
           <p:nvPr>
-            <p:ph idx="105" type="title" hasCustomPrompt="1"/>
+            <p:ph idx="104" type="title" hasCustomPrompt="1"/>
           </p:nvPr>
         </p:nvSpPr>
         <p:spPr>
@@ -10072,10 +10036,10 @@
       </p:grpSpPr>
       <p:sp>
         <p:nvSpPr>
-          <p:cNvPr id="2" name="Text 3"/>
+          <p:cNvPr id="2" name="Text 2"/>
           <p:cNvSpPr/>
           <p:nvPr>
-            <p:ph idx="105" type="title" hasCustomPrompt="1"/>
+            <p:ph idx="104" type="title" hasCustomPrompt="1"/>
           </p:nvPr>
         </p:nvSpPr>
         <p:spPr>
@@ -11095,10 +11059,10 @@
       </p:grpSpPr>
       <p:sp>
         <p:nvSpPr>
-          <p:cNvPr id="2" name="Text 3"/>
+          <p:cNvPr id="2" name="Text 2"/>
           <p:cNvSpPr/>
           <p:nvPr>
-            <p:ph idx="105" type="title" hasCustomPrompt="1"/>
+            <p:ph idx="104" type="title" hasCustomPrompt="1"/>
           </p:nvPr>
         </p:nvSpPr>
         <p:spPr>
@@ -12115,10 +12079,10 @@
       </p:grpSpPr>
       <p:sp>
         <p:nvSpPr>
-          <p:cNvPr id="2" name="Text 3"/>
+          <p:cNvPr id="2" name="Text 2"/>
           <p:cNvSpPr/>
           <p:nvPr>
-            <p:ph idx="105" type="title" hasCustomPrompt="1"/>
+            <p:ph idx="104" type="title" hasCustomPrompt="1"/>
           </p:nvPr>
         </p:nvSpPr>
         <p:spPr>
@@ -13052,10 +13016,10 @@
       </p:grpSpPr>
       <p:sp>
         <p:nvSpPr>
-          <p:cNvPr id="2" name="Text 3"/>
+          <p:cNvPr id="2" name="Text 2"/>
           <p:cNvSpPr/>
           <p:nvPr>
-            <p:ph idx="105" type="title" hasCustomPrompt="1"/>
+            <p:ph idx="104" type="title" hasCustomPrompt="1"/>
           </p:nvPr>
         </p:nvSpPr>
         <p:spPr>
@@ -14147,10 +14111,10 @@
       </p:grpSpPr>
       <p:sp>
         <p:nvSpPr>
-          <p:cNvPr id="2" name="Text 3"/>
+          <p:cNvPr id="2" name="Text 2"/>
           <p:cNvSpPr/>
           <p:nvPr>
-            <p:ph idx="105" type="title" hasCustomPrompt="1"/>
+            <p:ph idx="104" type="title" hasCustomPrompt="1"/>
           </p:nvPr>
         </p:nvSpPr>
         <p:spPr>
@@ -14757,10 +14721,10 @@
       </p:grpSpPr>
       <p:sp>
         <p:nvSpPr>
-          <p:cNvPr id="2" name="Text 3"/>
+          <p:cNvPr id="2" name="Text 2"/>
           <p:cNvSpPr/>
           <p:nvPr>
-            <p:ph idx="105" type="title" hasCustomPrompt="1"/>
+            <p:ph idx="104" type="title" hasCustomPrompt="1"/>
           </p:nvPr>
         </p:nvSpPr>
         <p:spPr>
@@ -15367,10 +15331,10 @@
       </p:grpSpPr>
       <p:sp>
         <p:nvSpPr>
-          <p:cNvPr id="2" name="Text 3"/>
+          <p:cNvPr id="2" name="Text 2"/>
           <p:cNvSpPr/>
           <p:nvPr>
-            <p:ph idx="105" type="title" hasCustomPrompt="1"/>
+            <p:ph idx="104" type="title" hasCustomPrompt="1"/>
           </p:nvPr>
         </p:nvSpPr>
         <p:spPr>
@@ -15977,10 +15941,10 @@
       </p:grpSpPr>
       <p:sp>
         <p:nvSpPr>
-          <p:cNvPr id="2" name="Text 3"/>
+          <p:cNvPr id="2" name="Text 2"/>
           <p:cNvSpPr/>
           <p:nvPr>
-            <p:ph idx="105" type="title" hasCustomPrompt="1"/>
+            <p:ph idx="104" type="title" hasCustomPrompt="1"/>
           </p:nvPr>
         </p:nvSpPr>
         <p:spPr>
@@ -16445,10 +16409,10 @@
       </p:grpSpPr>
       <p:sp>
         <p:nvSpPr>
-          <p:cNvPr id="2" name="Text 3"/>
+          <p:cNvPr id="2" name="Text 2"/>
           <p:cNvSpPr/>
           <p:nvPr>
-            <p:ph idx="105" type="title" hasCustomPrompt="1"/>
+            <p:ph idx="104" type="title" hasCustomPrompt="1"/>
           </p:nvPr>
         </p:nvSpPr>
         <p:spPr>
@@ -17321,10 +17285,10 @@
       </p:grpSpPr>
       <p:sp>
         <p:nvSpPr>
-          <p:cNvPr id="2" name="Text 3"/>
+          <p:cNvPr id="2" name="Text 2"/>
           <p:cNvSpPr/>
           <p:nvPr>
-            <p:ph idx="105" type="title" hasCustomPrompt="1"/>
+            <p:ph idx="104" type="title" hasCustomPrompt="1"/>
           </p:nvPr>
         </p:nvSpPr>
         <p:spPr>
@@ -18245,10 +18209,10 @@
       </p:grpSpPr>
       <p:sp>
         <p:nvSpPr>
-          <p:cNvPr id="2" name="Text 3"/>
+          <p:cNvPr id="2" name="Text 2"/>
           <p:cNvSpPr/>
           <p:nvPr>
-            <p:ph idx="105" type="title" hasCustomPrompt="1"/>
+            <p:ph idx="104" type="title" hasCustomPrompt="1"/>
           </p:nvPr>
         </p:nvSpPr>
         <p:spPr>

</xml_diff>